<commit_message>
updated proposal ppt and pdf
</commit_message>
<xml_diff>
--- a/proposal/proposal_super_long_wave.pptx
+++ b/proposal/proposal_super_long_wave.pptx
@@ -11324,7 +11324,7 @@
             <p:ph idx="1"/>
             <p:extLst>
               <p:ext uri="{D42A27DB-BD31-4B8C-83A1-F6EECF244321}">
-                <p14:modId xmlns:p14="http://schemas.microsoft.com/office/powerpoint/2010/main" val="3683869548"/>
+                <p14:modId xmlns:p14="http://schemas.microsoft.com/office/powerpoint/2010/main" val="568318852"/>
               </p:ext>
             </p:extLst>
           </p:nvPr>
@@ -11603,10 +11603,30 @@
                     <a:bodyPr/>
                     <a:lstStyle/>
                     <a:p>
+                      <a:pPr marL="0" marR="0" lvl="0" indent="0" algn="l" defTabSz="914400" rtl="0" eaLnBrk="1" fontAlgn="auto" latinLnBrk="0" hangingPunct="1">
+                        <a:lnSpc>
+                          <a:spcPct val="100000"/>
+                        </a:lnSpc>
+                        <a:spcBef>
+                          <a:spcPts val="0"/>
+                        </a:spcBef>
+                        <a:spcAft>
+                          <a:spcPts val="0"/>
+                        </a:spcAft>
+                        <a:buClrTx/>
+                        <a:buSzTx/>
+                        <a:buFontTx/>
+                        <a:buNone/>
+                        <a:tabLst/>
+                        <a:defRPr/>
+                      </a:pPr>
                       <a:r>
                         <a:rPr kumimoji="1" lang="en-US" altLang="ja-JP" dirty="0"/>
-                        <a:t>EE</a:t>
+                        <a:t>Bachelors in EE</a:t>
                       </a:r>
+                      <a:endParaRPr kumimoji="1" lang="ja-JP" altLang="en-US" dirty="0"/>
+                    </a:p>
+                    <a:p>
                       <a:endParaRPr kumimoji="1" lang="ja-JP" altLang="en-US" dirty="0"/>
                     </a:p>
                   </a:txBody>
@@ -11619,7 +11639,7 @@
                     <a:p>
                       <a:r>
                         <a:rPr kumimoji="1" lang="en-US" altLang="ja-JP" dirty="0"/>
-                        <a:t>Bachelors in EE</a:t>
+                        <a:t>EE</a:t>
                       </a:r>
                       <a:endParaRPr kumimoji="1" lang="ja-JP" altLang="en-US" dirty="0"/>
                     </a:p>
@@ -11670,18 +11690,30 @@
                     <a:bodyPr/>
                     <a:lstStyle/>
                     <a:p>
+                      <a:pPr marL="0" marR="0" lvl="0" indent="0" algn="l" defTabSz="914400" rtl="0" eaLnBrk="1" fontAlgn="auto" latinLnBrk="0" hangingPunct="1">
+                        <a:lnSpc>
+                          <a:spcPct val="100000"/>
+                        </a:lnSpc>
+                        <a:spcBef>
+                          <a:spcPts val="0"/>
+                        </a:spcBef>
+                        <a:spcAft>
+                          <a:spcPts val="0"/>
+                        </a:spcAft>
+                        <a:buClrTx/>
+                        <a:buSzTx/>
+                        <a:buFontTx/>
+                        <a:buNone/>
+                        <a:tabLst/>
+                        <a:defRPr/>
+                      </a:pPr>
                       <a:r>
                         <a:rPr kumimoji="1" lang="en-US" altLang="ja-JP" dirty="0"/>
-                        <a:t>Digital Design</a:t>
+                        <a:t>Analog Design Engineer with tape out experience</a:t>
                       </a:r>
-                      <a:r>
-                        <a:rPr kumimoji="1" lang="ja-JP" altLang="en-US" dirty="0"/>
-                        <a:t>　</a:t>
-                      </a:r>
-                      <a:r>
-                        <a:rPr kumimoji="1" lang="en-US" altLang="ja-JP" dirty="0"/>
-                        <a:t>Engineer</a:t>
-                      </a:r>
+                      <a:endParaRPr kumimoji="1" lang="ja-JP" altLang="en-US" dirty="0"/>
+                    </a:p>
+                    <a:p>
                       <a:endParaRPr kumimoji="1" lang="ja-JP" altLang="en-US" dirty="0"/>
                     </a:p>
                   </a:txBody>
@@ -11694,7 +11726,15 @@
                     <a:p>
                       <a:r>
                         <a:rPr kumimoji="1" lang="en-US" altLang="ja-JP" dirty="0"/>
-                        <a:t>Analog Design Engineer with tape out experience</a:t>
+                        <a:t>Digital Design</a:t>
+                      </a:r>
+                      <a:r>
+                        <a:rPr kumimoji="1" lang="ja-JP" altLang="en-US" dirty="0"/>
+                        <a:t>　</a:t>
+                      </a:r>
+                      <a:r>
+                        <a:rPr kumimoji="1" lang="en-US" altLang="ja-JP" dirty="0"/>
+                        <a:t>Engineer</a:t>
                       </a:r>
                       <a:endParaRPr kumimoji="1" lang="ja-JP" altLang="en-US" dirty="0"/>
                     </a:p>

</xml_diff>

<commit_message>
expanded operating frequency range of vco
</commit_message>
<xml_diff>
--- a/proposal/proposal_super_long_wave.pptx
+++ b/proposal/proposal_super_long_wave.pptx
@@ -20,7 +20,7 @@
     <p:sldId id="290" r:id="rId11"/>
     <p:sldId id="291" r:id="rId12"/>
     <p:sldId id="280" r:id="rId13"/>
-    <p:sldId id="282" r:id="rId14"/>
+    <p:sldId id="292" r:id="rId14"/>
     <p:sldId id="284" r:id="rId15"/>
   </p:sldIdLst>
   <p:sldSz cx="12192000" cy="6858000"/>
@@ -2416,7 +2416,7 @@
           <a:p>
             <a:fld id="{9D6ED843-FBAC-4BF9-84F2-6CB52D7BC460}" type="datetimeFigureOut">
               <a:rPr kumimoji="1" lang="ja-JP" altLang="en-US" smtClean="0"/>
-              <a:t>2026/5/28</a:t>
+              <a:t>2026/5/29</a:t>
             </a:fld>
             <a:endParaRPr kumimoji="1" lang="ja-JP" altLang="en-US"/>
           </a:p>
@@ -3714,7 +3714,7 @@
           <a:p>
             <a:fld id="{F5B9BC23-ACCF-40B7-9F8A-C869B7D2A964}" type="datetime1">
               <a:rPr lang="en-US" altLang="ja-JP" smtClean="0"/>
-              <a:t>5/28/2026</a:t>
+              <a:t>5/29/2026</a:t>
             </a:fld>
             <a:endParaRPr lang="en-US"/>
           </a:p>
@@ -4202,7 +4202,7 @@
           <a:p>
             <a:fld id="{B5A44078-B338-4B71-BD47-0F234CD99180}" type="datetime1">
               <a:rPr lang="en-US" altLang="ja-JP" smtClean="0"/>
-              <a:t>5/28/2026</a:t>
+              <a:t>5/29/2026</a:t>
             </a:fld>
             <a:endParaRPr lang="en-US"/>
           </a:p>
@@ -4367,7 +4367,7 @@
           <a:p>
             <a:fld id="{865A1777-293B-44C6-BDCA-81A8114C1E32}" type="datetime1">
               <a:rPr lang="en-US" altLang="ja-JP" smtClean="0"/>
-              <a:t>5/28/2026</a:t>
+              <a:t>5/29/2026</a:t>
             </a:fld>
             <a:endParaRPr lang="en-US"/>
           </a:p>
@@ -4511,7 +4511,7 @@
           <a:p>
             <a:fld id="{619C993C-504F-4161-B648-BC81B6CDF032}" type="datetime1">
               <a:rPr lang="en-US" altLang="ja-JP" smtClean="0"/>
-              <a:t>5/28/2026</a:t>
+              <a:t>5/29/2026</a:t>
             </a:fld>
             <a:endParaRPr lang="en-US"/>
           </a:p>
@@ -4776,7 +4776,7 @@
           <a:p>
             <a:fld id="{5BCF4F73-EC84-473A-9021-5AE2CF45038E}" type="datetime1">
               <a:rPr lang="en-US" altLang="ja-JP" smtClean="0"/>
-              <a:t>5/28/2026</a:t>
+              <a:t>5/29/2026</a:t>
             </a:fld>
             <a:endParaRPr lang="en-US"/>
           </a:p>
@@ -5648,7 +5648,7 @@
           <a:p>
             <a:fld id="{CCC4E1EE-9E13-4C2D-AFC1-1D3561D21B1A}" type="datetime1">
               <a:rPr lang="en-US" altLang="ja-JP" smtClean="0"/>
-              <a:t>5/28/2026</a:t>
+              <a:t>5/29/2026</a:t>
             </a:fld>
             <a:endParaRPr lang="en-US"/>
           </a:p>
@@ -6392,10 +6392,10 @@
       </p:sp>
       <p:pic>
         <p:nvPicPr>
-          <p:cNvPr id="2" name="図 1">
+          <p:cNvPr id="11" name="図 10">
             <a:extLst>
               <a:ext uri="{FF2B5EF4-FFF2-40B4-BE49-F238E27FC236}">
-                <a16:creationId xmlns:a16="http://schemas.microsoft.com/office/drawing/2014/main" id="{6C7BAE00-CC91-7BCA-BACC-F6E680170F9C}"/>
+                <a16:creationId xmlns:a16="http://schemas.microsoft.com/office/drawing/2014/main" id="{140F37FD-1B7D-8EE9-6493-A8745907E257}"/>
               </a:ext>
             </a:extLst>
           </p:cNvPr>
@@ -6412,68 +6412,8 @@
         </p:blipFill>
         <p:spPr>
           <a:xfrm>
-            <a:off x="282804" y="3527466"/>
-            <a:ext cx="7062397" cy="3096056"/>
-          </a:xfrm>
-          <a:prstGeom prst="rect">
-            <a:avLst/>
-          </a:prstGeom>
-        </p:spPr>
-      </p:pic>
-      <p:pic>
-        <p:nvPicPr>
-          <p:cNvPr id="6" name="図 5">
-            <a:extLst>
-              <a:ext uri="{FF2B5EF4-FFF2-40B4-BE49-F238E27FC236}">
-                <a16:creationId xmlns:a16="http://schemas.microsoft.com/office/drawing/2014/main" id="{01921FDB-084B-5C09-5054-FB56E4D3EED0}"/>
-              </a:ext>
-            </a:extLst>
-          </p:cNvPr>
-          <p:cNvPicPr>
-            <a:picLocks noChangeAspect="1"/>
-          </p:cNvPicPr>
-          <p:nvPr/>
-        </p:nvPicPr>
-        <p:blipFill>
-          <a:blip r:embed="rId3"/>
-          <a:stretch>
-            <a:fillRect/>
-          </a:stretch>
-        </p:blipFill>
-        <p:spPr>
-          <a:xfrm>
-            <a:off x="7494887" y="3527465"/>
-            <a:ext cx="4115374" cy="3096057"/>
-          </a:xfrm>
-          <a:prstGeom prst="rect">
-            <a:avLst/>
-          </a:prstGeom>
-        </p:spPr>
-      </p:pic>
-      <p:pic>
-        <p:nvPicPr>
-          <p:cNvPr id="7" name="図 6">
-            <a:extLst>
-              <a:ext uri="{FF2B5EF4-FFF2-40B4-BE49-F238E27FC236}">
-                <a16:creationId xmlns:a16="http://schemas.microsoft.com/office/drawing/2014/main" id="{39389687-9359-4FF2-0518-B20E7DADED62}"/>
-              </a:ext>
-            </a:extLst>
-          </p:cNvPr>
-          <p:cNvPicPr>
-            <a:picLocks noChangeAspect="1"/>
-          </p:cNvPicPr>
-          <p:nvPr/>
-        </p:nvPicPr>
-        <p:blipFill>
-          <a:blip r:embed="rId4"/>
-          <a:stretch>
-            <a:fillRect/>
-          </a:stretch>
-        </p:blipFill>
-        <p:spPr>
-          <a:xfrm>
-            <a:off x="7494888" y="1211633"/>
-            <a:ext cx="4115374" cy="2226138"/>
+            <a:off x="950407" y="1426586"/>
+            <a:ext cx="10157836" cy="4628622"/>
           </a:xfrm>
           <a:prstGeom prst="rect">
             <a:avLst/>
@@ -6880,7 +6820,13 @@
   <p:cSld>
     <p:spTree>
       <p:nvGrpSpPr>
-        <p:cNvPr id="1" name=""/>
+        <p:cNvPr id="1" name="">
+          <a:extLst>
+            <a:ext uri="{FF2B5EF4-FFF2-40B4-BE49-F238E27FC236}">
+              <a16:creationId xmlns:a16="http://schemas.microsoft.com/office/drawing/2014/main" id="{FE77CF2A-7FBC-C952-12BC-0F025F245EF7}"/>
+            </a:ext>
+          </a:extLst>
+        </p:cNvPr>
         <p:cNvGrpSpPr/>
         <p:nvPr/>
       </p:nvGrpSpPr>
@@ -6897,7 +6843,7 @@
           <p:cNvPr id="2" name="コンテンツ プレースホルダー 1">
             <a:extLst>
               <a:ext uri="{FF2B5EF4-FFF2-40B4-BE49-F238E27FC236}">
-                <a16:creationId xmlns:a16="http://schemas.microsoft.com/office/drawing/2014/main" id="{8E821E95-ADA8-046E-B08F-1B5A0774B94D}"/>
+                <a16:creationId xmlns:a16="http://schemas.microsoft.com/office/drawing/2014/main" id="{C3E15046-66AA-FC43-584A-5C772E332219}"/>
               </a:ext>
             </a:extLst>
           </p:cNvPr>
@@ -6922,7 +6868,7 @@
           <p:cNvPr id="3" name="コンテンツ プレースホルダー 2">
             <a:extLst>
               <a:ext uri="{FF2B5EF4-FFF2-40B4-BE49-F238E27FC236}">
-                <a16:creationId xmlns:a16="http://schemas.microsoft.com/office/drawing/2014/main" id="{50097931-AB23-7D29-D4E6-D31B4564B00B}"/>
+                <a16:creationId xmlns:a16="http://schemas.microsoft.com/office/drawing/2014/main" id="{20C4BD6D-EA90-E20C-9C47-E0732A371C04}"/>
               </a:ext>
             </a:extLst>
           </p:cNvPr>
@@ -6939,14 +6885,8 @@
           <a:lstStyle/>
           <a:p>
             <a:r>
-              <a:rPr kumimoji="1" lang="en-US" altLang="ja-JP" dirty="0"/>
-              <a:t>Put evaluation result here</a:t>
-            </a:r>
-          </a:p>
-          <a:p>
-            <a:r>
               <a:rPr lang="en-US" altLang="ja-JP" dirty="0"/>
-              <a:t>Insert graph to left</a:t>
+              <a:t>to left</a:t>
             </a:r>
             <a:endParaRPr kumimoji="1" lang="ja-JP" altLang="en-US" dirty="0"/>
           </a:p>
@@ -6957,7 +6897,7 @@
           <p:cNvPr id="4" name="タイトル 3">
             <a:extLst>
               <a:ext uri="{FF2B5EF4-FFF2-40B4-BE49-F238E27FC236}">
-                <a16:creationId xmlns:a16="http://schemas.microsoft.com/office/drawing/2014/main" id="{CC843D2A-552D-462C-8120-7EA63ECC3949}"/>
+                <a16:creationId xmlns:a16="http://schemas.microsoft.com/office/drawing/2014/main" id="{0ACD9F9A-3907-BC87-B810-905B823A4AF3}"/>
               </a:ext>
             </a:extLst>
           </p:cNvPr>
@@ -6975,7 +6915,7 @@
           <a:p>
             <a:r>
               <a:rPr lang="en-US" altLang="ja-JP" dirty="0"/>
-              <a:t>Evaluation  (T.B.D)</a:t>
+              <a:t>Evaluation - OPAMP</a:t>
             </a:r>
             <a:endParaRPr kumimoji="1" lang="ja-JP" altLang="en-US" dirty="0"/>
           </a:p>
@@ -6986,7 +6926,7 @@
           <p:cNvPr id="5" name="スライド番号プレースホルダー 4">
             <a:extLst>
               <a:ext uri="{FF2B5EF4-FFF2-40B4-BE49-F238E27FC236}">
-                <a16:creationId xmlns:a16="http://schemas.microsoft.com/office/drawing/2014/main" id="{5652CE29-8A9D-6409-11C7-265EF3F9D623}"/>
+                <a16:creationId xmlns:a16="http://schemas.microsoft.com/office/drawing/2014/main" id="{F20A4E47-D9D0-332F-A763-40DAAA1CFCA2}"/>
               </a:ext>
             </a:extLst>
           </p:cNvPr>
@@ -7010,10 +6950,70 @@
           </a:p>
         </p:txBody>
       </p:sp>
+      <p:pic>
+        <p:nvPicPr>
+          <p:cNvPr id="7" name="図 6">
+            <a:extLst>
+              <a:ext uri="{FF2B5EF4-FFF2-40B4-BE49-F238E27FC236}">
+                <a16:creationId xmlns:a16="http://schemas.microsoft.com/office/drawing/2014/main" id="{AD184B53-A5A4-7E43-28E0-8A0DAFB97250}"/>
+              </a:ext>
+            </a:extLst>
+          </p:cNvPr>
+          <p:cNvPicPr>
+            <a:picLocks noChangeAspect="1"/>
+          </p:cNvPicPr>
+          <p:nvPr/>
+        </p:nvPicPr>
+        <p:blipFill>
+          <a:blip r:embed="rId2"/>
+          <a:stretch>
+            <a:fillRect/>
+          </a:stretch>
+        </p:blipFill>
+        <p:spPr>
+          <a:xfrm>
+            <a:off x="375600" y="1486918"/>
+            <a:ext cx="7185317" cy="3886769"/>
+          </a:xfrm>
+          <a:prstGeom prst="rect">
+            <a:avLst/>
+          </a:prstGeom>
+        </p:spPr>
+      </p:pic>
+      <p:pic>
+        <p:nvPicPr>
+          <p:cNvPr id="6" name="図 5">
+            <a:extLst>
+              <a:ext uri="{FF2B5EF4-FFF2-40B4-BE49-F238E27FC236}">
+                <a16:creationId xmlns:a16="http://schemas.microsoft.com/office/drawing/2014/main" id="{ECAEE455-B8AA-9C44-FA9A-68D4270D7BFE}"/>
+              </a:ext>
+            </a:extLst>
+          </p:cNvPr>
+          <p:cNvPicPr>
+            <a:picLocks noChangeAspect="1"/>
+          </p:cNvPicPr>
+          <p:nvPr/>
+        </p:nvPicPr>
+        <p:blipFill>
+          <a:blip r:embed="rId3"/>
+          <a:stretch>
+            <a:fillRect/>
+          </a:stretch>
+        </p:blipFill>
+        <p:spPr>
+          <a:xfrm>
+            <a:off x="7776589" y="1484313"/>
+            <a:ext cx="4115374" cy="3096057"/>
+          </a:xfrm>
+          <a:prstGeom prst="rect">
+            <a:avLst/>
+          </a:prstGeom>
+        </p:spPr>
+      </p:pic>
     </p:spTree>
     <p:extLst>
       <p:ext uri="{BB962C8B-B14F-4D97-AF65-F5344CB8AC3E}">
-        <p14:creationId xmlns:p14="http://schemas.microsoft.com/office/powerpoint/2010/main" val="519559728"/>
+        <p14:creationId xmlns:p14="http://schemas.microsoft.com/office/powerpoint/2010/main" val="718054095"/>
       </p:ext>
     </p:extLst>
   </p:cSld>
@@ -11855,7 +11855,7 @@
             <p:ph sz="half" idx="1"/>
             <p:extLst>
               <p:ext uri="{D42A27DB-BD31-4B8C-83A1-F6EECF244321}">
-                <p14:modId xmlns:p14="http://schemas.microsoft.com/office/powerpoint/2010/main" val="2908780152"/>
+                <p14:modId xmlns:p14="http://schemas.microsoft.com/office/powerpoint/2010/main" val="2283301717"/>
               </p:ext>
             </p:extLst>
           </p:nvPr>
@@ -11986,7 +11986,7 @@
                       <a:pPr algn="ctr"/>
                       <a:r>
                         <a:rPr kumimoji="1" lang="en-US" altLang="ja-JP" sz="1600" dirty="0"/>
-                        <a:t>11</a:t>
+                        <a:t>9</a:t>
                       </a:r>
                       <a:endParaRPr kumimoji="1" lang="ja-JP" altLang="en-US" sz="1600" dirty="0"/>
                     </a:p>
@@ -12399,14 +12399,14 @@
             <p:ph sz="half" idx="2"/>
             <p:extLst>
               <p:ext uri="{D42A27DB-BD31-4B8C-83A1-F6EECF244321}">
-                <p14:modId xmlns:p14="http://schemas.microsoft.com/office/powerpoint/2010/main" val="3234085023"/>
+                <p14:modId xmlns:p14="http://schemas.microsoft.com/office/powerpoint/2010/main" val="1254683123"/>
               </p:ext>
             </p:extLst>
           </p:nvPr>
         </p:nvGraphicFramePr>
         <p:xfrm>
           <a:off x="6096000" y="1304924"/>
-          <a:ext cx="5416866" cy="4866640"/>
+          <a:ext cx="5416866" cy="3916680"/>
         </p:xfrm>
         <a:graphic>
           <a:graphicData uri="http://schemas.openxmlformats.org/drawingml/2006/table">
@@ -12864,121 +12864,6 @@
                     <a:bodyPr/>
                     <a:lstStyle/>
                     <a:p>
-                      <a:r>
-                        <a:rPr kumimoji="1" lang="en-US" altLang="ja-JP" sz="1600" dirty="0"/>
-                        <a:t>EXT_FIL_OUT</a:t>
-                      </a:r>
-                      <a:endParaRPr kumimoji="1" lang="ja-JP" altLang="en-US" sz="1600" dirty="0"/>
-                    </a:p>
-                  </a:txBody>
-                  <a:tcPr/>
-                </a:tc>
-                <a:tc>
-                  <a:txBody>
-                    <a:bodyPr/>
-                    <a:lstStyle/>
-                    <a:p>
-                      <a:r>
-                        <a:rPr kumimoji="1" lang="en-US" altLang="ja-JP" sz="1600" dirty="0"/>
-                        <a:t>To Band pass filter 10.7MHz</a:t>
-                      </a:r>
-                      <a:endParaRPr kumimoji="1" lang="ja-JP" altLang="en-US" sz="1600" dirty="0"/>
-                    </a:p>
-                  </a:txBody>
-                  <a:tcPr/>
-                </a:tc>
-                <a:extLst>
-                  <a:ext uri="{0D108BD9-81ED-4DB2-BD59-A6C34878D82A}">
-                    <a16:rowId xmlns:a16="http://schemas.microsoft.com/office/drawing/2014/main" val="1076122031"/>
-                  </a:ext>
-                </a:extLst>
-              </a:tr>
-              <a:tr h="370840">
-                <a:tc>
-                  <a:txBody>
-                    <a:bodyPr/>
-                    <a:lstStyle/>
-                    <a:p>
-                      <a:r>
-                        <a:rPr kumimoji="1" lang="en-US" altLang="ja-JP" sz="1600" dirty="0"/>
-                        <a:t>9</a:t>
-                      </a:r>
-                      <a:endParaRPr kumimoji="1" lang="ja-JP" altLang="en-US" sz="1600" dirty="0"/>
-                    </a:p>
-                  </a:txBody>
-                  <a:tcPr/>
-                </a:tc>
-                <a:tc>
-                  <a:txBody>
-                    <a:bodyPr/>
-                    <a:lstStyle/>
-                    <a:p>
-                      <a:pPr marL="0" marR="0" lvl="0" indent="0" algn="l" defTabSz="914400" rtl="0" eaLnBrk="1" fontAlgn="auto" latinLnBrk="0" hangingPunct="1">
-                        <a:lnSpc>
-                          <a:spcPct val="100000"/>
-                        </a:lnSpc>
-                        <a:spcBef>
-                          <a:spcPts val="0"/>
-                        </a:spcBef>
-                        <a:spcAft>
-                          <a:spcPts val="0"/>
-                        </a:spcAft>
-                        <a:buClrTx/>
-                        <a:buSzTx/>
-                        <a:buFontTx/>
-                        <a:buNone/>
-                        <a:tabLst/>
-                        <a:defRPr/>
-                      </a:pPr>
-                      <a:r>
-                        <a:rPr kumimoji="1" lang="en-US" altLang="ja-JP" sz="1600" dirty="0"/>
-                        <a:t>EXT_FIL_IN</a:t>
-                      </a:r>
-                      <a:endParaRPr kumimoji="1" lang="ja-JP" altLang="en-US" sz="1600" dirty="0"/>
-                    </a:p>
-                  </a:txBody>
-                  <a:tcPr/>
-                </a:tc>
-                <a:tc>
-                  <a:txBody>
-                    <a:bodyPr/>
-                    <a:lstStyle/>
-                    <a:p>
-                      <a:r>
-                        <a:rPr kumimoji="1" lang="en-US" altLang="ja-JP" sz="1600" dirty="0"/>
-                        <a:t>From Band pass filter 10.7MHz</a:t>
-                      </a:r>
-                      <a:endParaRPr kumimoji="1" lang="ja-JP" altLang="en-US" sz="1600" dirty="0"/>
-                    </a:p>
-                  </a:txBody>
-                  <a:tcPr/>
-                </a:tc>
-                <a:extLst>
-                  <a:ext uri="{0D108BD9-81ED-4DB2-BD59-A6C34878D82A}">
-                    <a16:rowId xmlns:a16="http://schemas.microsoft.com/office/drawing/2014/main" val="2927757653"/>
-                  </a:ext>
-                </a:extLst>
-              </a:tr>
-              <a:tr h="370840">
-                <a:tc>
-                  <a:txBody>
-                    <a:bodyPr/>
-                    <a:lstStyle/>
-                    <a:p>
-                      <a:r>
-                        <a:rPr kumimoji="1" lang="en-US" altLang="ja-JP" sz="1600" dirty="0"/>
-                        <a:t>10</a:t>
-                      </a:r>
-                      <a:endParaRPr kumimoji="1" lang="ja-JP" altLang="en-US" sz="1600" dirty="0"/>
-                    </a:p>
-                  </a:txBody>
-                  <a:tcPr/>
-                </a:tc>
-                <a:tc>
-                  <a:txBody>
-                    <a:bodyPr/>
-                    <a:lstStyle/>
-                    <a:p>
                       <a:pPr marL="0" marR="0" lvl="0" indent="0" algn="l" defTabSz="914400" rtl="0" eaLnBrk="1" fontAlgn="auto" latinLnBrk="0" hangingPunct="1">
                         <a:lnSpc>
                           <a:spcPct val="100000"/>
@@ -13050,7 +12935,7 @@
                     <a:p>
                       <a:r>
                         <a:rPr kumimoji="1" lang="en-US" altLang="ja-JP" sz="1600" dirty="0"/>
-                        <a:t>11</a:t>
+                        <a:t>9</a:t>
                       </a:r>
                       <a:endParaRPr kumimoji="1" lang="ja-JP" altLang="en-US" sz="1600" dirty="0"/>
                     </a:p>

</xml_diff>